<commit_message>
PPTX Agenda: logo GS1 Venezuela y fotos extraídos del afiche oficial
Co-Authored-By: Claude Sonnet 5.5 <noreply@anthropic.com>
Claude-Session: https://claude.ai/code/session_01SZenMW1fww8JkTjePJkRxL
</commit_message>
<xml_diff>
--- a/presentaciones/comite-salud-gs1/Comite-Salud-GS1-Agenda.pptx
+++ b/presentaciones/comite-salud-gs1/Comite-Salud-GS1-Agenda.pptx
@@ -2291,8 +2291,8 @@
         </p:blipFill>
         <p:spPr>
           <a:xfrm>
-            <a:off x="533400" y="323850"/>
-            <a:ext cx="1905000" cy="533400"/>
+            <a:off x="457200" y="190500"/>
+            <a:ext cx="1600200" cy="800100"/>
           </a:xfrm>
           <a:prstGeom prst="rect">
             <a:avLst/>
@@ -2994,43 +2994,9 @@
           </a:p>
         </p:txBody>
       </p:sp>
-      <p:sp>
-        <p:nvSpPr>
-          <p:cNvPr id="26" name="FOTO (reemplazar): atención médica"/>
-          <p:cNvSpPr/>
-          <p:nvPr/>
-        </p:nvSpPr>
-        <p:spPr>
-          <a:xfrm rot="360000">
-            <a:off x="8096250" y="1428750"/>
-            <a:ext cx="2476500" cy="4000500"/>
-          </a:xfrm>
-          <a:prstGeom prst="roundRect">
-            <a:avLst>
-              <a:gd name="adj" fmla="val 12923"/>
-            </a:avLst>
-          </a:prstGeom>
-          <a:solidFill>
-            <a:schemeClr val="accent6"/>
-          </a:solidFill>
-          <a:ln w="38100">
-            <a:solidFill>
-              <a:schemeClr val="bg1"/>
-            </a:solidFill>
-            <a:prstDash val="solid"/>
-          </a:ln>
-          <a:effectLst>
-            <a:outerShdw sx="100000" sy="100000" kx="0" ky="0" algn="bl" rotWithShape="0" blurRad="177800" dist="38100" dir="5400000">
-              <a:srgbClr val="1E3A8A">
-                <a:alpha val="14000"/>
-              </a:srgbClr>
-            </a:outerShdw>
-          </a:effectLst>
-        </p:spPr>
-      </p:sp>
       <p:pic>
         <p:nvPicPr>
-          <p:cNvPr id="27" name="Image 9" descr="Icono Stethoscope">    </p:cNvPr>
+          <p:cNvPr id="26" name="Image 9" descr="Médico y paciente">    </p:cNvPr>
           <p:cNvPicPr>
             <a:picLocks noChangeAspect="1"/>
           </p:cNvPicPr>
@@ -3043,86 +3009,18 @@
           </a:stretch>
         </p:blipFill>
         <p:spPr>
-          <a:xfrm>
-            <a:off x="8863965" y="2958465"/>
-            <a:ext cx="941070" cy="941070"/>
+          <a:xfrm rot="360000">
+            <a:off x="7953375" y="1428750"/>
+            <a:ext cx="2628900" cy="4248150"/>
           </a:xfrm>
           <a:prstGeom prst="rect">
             <a:avLst/>
           </a:prstGeom>
         </p:spPr>
       </p:pic>
-      <p:sp>
-        <p:nvSpPr>
-          <p:cNvPr id="28" name="Etiqueta foto"/>
-          <p:cNvSpPr txBox="1"/>
-          <p:nvPr/>
-        </p:nvSpPr>
-        <p:spPr>
-          <a:xfrm>
-            <a:off x="8172450" y="5181600"/>
-            <a:ext cx="2324100" cy="152400"/>
-          </a:xfrm>
-          <a:prstGeom prst="rect">
-            <a:avLst/>
-          </a:prstGeom>
-          <a:noFill/>
-          <a:ln/>
-        </p:spPr>
-        <p:txBody>
-          <a:bodyPr wrap="square" lIns="0" tIns="0" rIns="0" bIns="0" rtlCol="0" anchor="t"/>
-          <a:lstStyle/>
-          <a:p>
-            <a:pPr algn="ctr" indent="0" marL="0">
-              <a:buNone/>
-            </a:pPr>
-            <a:r>
-              <a:rPr lang="en-US" sz="800" dirty="0">
-                <a:solidFill>
-                  <a:schemeClr val="bg1"/>
-                </a:solidFill>
-              </a:rPr>
-              <a:t>Insertar foto: atención médica</a:t>
-            </a:r>
-            <a:endParaRPr lang="en-US" sz="800" dirty="0"/>
-          </a:p>
-        </p:txBody>
-      </p:sp>
-      <p:sp>
-        <p:nvSpPr>
-          <p:cNvPr id="29" name="FOTO (reemplazar): médico"/>
-          <p:cNvSpPr/>
-          <p:nvPr/>
-        </p:nvSpPr>
-        <p:spPr>
-          <a:xfrm>
-            <a:off x="7048500" y="3028950"/>
-            <a:ext cx="2190750" cy="2190750"/>
-          </a:xfrm>
-          <a:prstGeom prst="ellipse">
-            <a:avLst/>
-          </a:prstGeom>
-          <a:solidFill>
-            <a:schemeClr val="tx2"/>
-          </a:solidFill>
-          <a:ln w="63500">
-            <a:solidFill>
-              <a:schemeClr val="bg1"/>
-            </a:solidFill>
-            <a:prstDash val="solid"/>
-          </a:ln>
-          <a:effectLst>
-            <a:outerShdw sx="100000" sy="100000" kx="0" ky="0" algn="bl" rotWithShape="0" blurRad="177800" dist="38100" dir="5400000">
-              <a:srgbClr val="1E3A8A">
-                <a:alpha val="14000"/>
-              </a:srgbClr>
-            </a:outerShdw>
-          </a:effectLst>
-        </p:spPr>
-      </p:sp>
       <p:pic>
         <p:nvPicPr>
-          <p:cNvPr id="30" name="Image 10" descr="Icono User">    </p:cNvPr>
+          <p:cNvPr id="27" name="Image 10" descr="Médico con iconos de salud y protección">    </p:cNvPr>
           <p:cNvPicPr>
             <a:picLocks noChangeAspect="1"/>
           </p:cNvPicPr>
@@ -3136,8 +3034,8 @@
         </p:blipFill>
         <p:spPr>
           <a:xfrm>
-            <a:off x="7727633" y="3708083"/>
-            <a:ext cx="832485" cy="832485"/>
+            <a:off x="6953250" y="3028950"/>
+            <a:ext cx="2381250" cy="2381250"/>
           </a:xfrm>
           <a:prstGeom prst="rect">
             <a:avLst/>
@@ -3146,43 +3044,7 @@
       </p:pic>
       <p:sp>
         <p:nvSpPr>
-          <p:cNvPr id="31" name="Etiqueta foto"/>
-          <p:cNvSpPr txBox="1"/>
-          <p:nvPr/>
-        </p:nvSpPr>
-        <p:spPr>
-          <a:xfrm>
-            <a:off x="7124700" y="4972050"/>
-            <a:ext cx="2038350" cy="152400"/>
-          </a:xfrm>
-          <a:prstGeom prst="rect">
-            <a:avLst/>
-          </a:prstGeom>
-          <a:noFill/>
-          <a:ln/>
-        </p:spPr>
-        <p:txBody>
-          <a:bodyPr wrap="square" lIns="0" tIns="0" rIns="0" bIns="0" rtlCol="0" anchor="t"/>
-          <a:lstStyle/>
-          <a:p>
-            <a:pPr algn="ctr" indent="0" marL="0">
-              <a:buNone/>
-            </a:pPr>
-            <a:r>
-              <a:rPr lang="en-US" sz="800" dirty="0">
-                <a:solidFill>
-                  <a:schemeClr val="bg1"/>
-                </a:solidFill>
-              </a:rPr>
-              <a:t>Insertar foto: médico</a:t>
-            </a:r>
-            <a:endParaRPr lang="en-US" sz="800" dirty="0"/>
-          </a:p>
-        </p:txBody>
-      </p:sp>
-      <p:sp>
-        <p:nvSpPr>
-          <p:cNvPr id="32" name="Círculo"/>
+          <p:cNvPr id="28" name="Círculo"/>
           <p:cNvSpPr/>
           <p:nvPr/>
         </p:nvSpPr>
@@ -3214,7 +3076,7 @@
       </p:sp>
       <p:sp>
         <p:nvSpPr>
-          <p:cNvPr id="33" name="Text 20"/>
+          <p:cNvPr id="29" name="Text 16"/>
           <p:cNvSpPr txBox="1"/>
           <p:nvPr/>
         </p:nvSpPr>
@@ -3250,7 +3112,7 @@
       </p:sp>
       <p:sp>
         <p:nvSpPr>
-          <p:cNvPr id="34" name="Icono ShieldCheck"/>
+          <p:cNvPr id="30" name="Icono ShieldCheck"/>
           <p:cNvSpPr/>
           <p:nvPr/>
         </p:nvSpPr>
@@ -3270,7 +3132,7 @@
       </p:sp>
       <p:pic>
         <p:nvPicPr>
-          <p:cNvPr id="35" name="Image 11" descr="Icono ShieldCheck">    </p:cNvPr>
+          <p:cNvPr id="31" name="Image 11" descr="Icono ShieldCheck">    </p:cNvPr>
           <p:cNvPicPr>
             <a:picLocks noChangeAspect="1"/>
           </p:cNvPicPr>
@@ -3294,7 +3156,7 @@
       </p:pic>
       <p:pic>
         <p:nvPicPr>
-          <p:cNvPr id="36" name="Image 12" descr="Icono Phone">    </p:cNvPr>
+          <p:cNvPr id="32" name="Image 12" descr="Icono Phone">    </p:cNvPr>
           <p:cNvPicPr>
             <a:picLocks noChangeAspect="1"/>
           </p:cNvPicPr>
@@ -3318,7 +3180,7 @@
       </p:pic>
       <p:sp>
         <p:nvSpPr>
-          <p:cNvPr id="37" name="Text 22"/>
+          <p:cNvPr id="33" name="Text 18"/>
           <p:cNvSpPr txBox="1"/>
           <p:nvPr/>
         </p:nvSpPr>
@@ -3354,7 +3216,7 @@
       </p:sp>
       <p:pic>
         <p:nvPicPr>
-          <p:cNvPr id="38" name="Image 13" descr="Icono Globe">    </p:cNvPr>
+          <p:cNvPr id="34" name="Image 13" descr="Icono Globe">    </p:cNvPr>
           <p:cNvPicPr>
             <a:picLocks noChangeAspect="1"/>
           </p:cNvPicPr>
@@ -3378,7 +3240,7 @@
       </p:pic>
       <p:sp>
         <p:nvSpPr>
-          <p:cNvPr id="39" name="Text 23"/>
+          <p:cNvPr id="35" name="Text 19"/>
           <p:cNvSpPr txBox="1"/>
           <p:nvPr/>
         </p:nvSpPr>
@@ -4402,8 +4264,8 @@
         </p:blipFill>
         <p:spPr>
           <a:xfrm>
-            <a:off x="4953000" y="323850"/>
-            <a:ext cx="1905000" cy="533400"/>
+            <a:off x="4876800" y="190500"/>
+            <a:ext cx="1600200" cy="800100"/>
           </a:xfrm>
           <a:prstGeom prst="rect">
             <a:avLst/>
@@ -10831,43 +10693,9 @@
           </a:p>
         </p:txBody>
       </p:sp>
-      <p:sp>
-        <p:nvSpPr>
-          <p:cNvPr id="5" name="FOTO (reemplazar): enfermera escaneando brazalete"/>
-          <p:cNvSpPr/>
-          <p:nvPr/>
-        </p:nvSpPr>
-        <p:spPr>
-          <a:xfrm rot="-240000">
-            <a:off x="571500" y="1524000"/>
-            <a:ext cx="2381250" cy="3810000"/>
-          </a:xfrm>
-          <a:prstGeom prst="roundRect">
-            <a:avLst>
-              <a:gd name="adj" fmla="val 13440"/>
-            </a:avLst>
-          </a:prstGeom>
-          <a:solidFill>
-            <a:schemeClr val="tx2"/>
-          </a:solidFill>
-          <a:ln w="38100">
-            <a:solidFill>
-              <a:schemeClr val="bg1"/>
-            </a:solidFill>
-            <a:prstDash val="solid"/>
-          </a:ln>
-          <a:effectLst>
-            <a:outerShdw sx="100000" sy="100000" kx="0" ky="0" algn="bl" rotWithShape="0" blurRad="177800" dist="38100" dir="5400000">
-              <a:srgbClr val="1E3A8A">
-                <a:alpha val="14000"/>
-              </a:srgbClr>
-            </a:outerShdw>
-          </a:effectLst>
-        </p:spPr>
-      </p:sp>
       <p:pic>
         <p:nvPicPr>
-          <p:cNvPr id="6" name="Image 0" descr="Icono HeartPulse">    </p:cNvPr>
+          <p:cNvPr id="5" name="Image 0" descr="Médico sosteniendo la mano del paciente">    </p:cNvPr>
           <p:cNvPicPr>
             <a:picLocks noChangeAspect="1"/>
           </p:cNvPicPr>
@@ -10880,86 +10708,18 @@
           </a:stretch>
         </p:blipFill>
         <p:spPr>
-          <a:xfrm>
-            <a:off x="1309688" y="2976563"/>
-            <a:ext cx="904875" cy="904875"/>
+          <a:xfrm rot="-240000">
+            <a:off x="571500" y="1524000"/>
+            <a:ext cx="2381250" cy="3848100"/>
           </a:xfrm>
           <a:prstGeom prst="rect">
             <a:avLst/>
           </a:prstGeom>
         </p:spPr>
       </p:pic>
-      <p:sp>
-        <p:nvSpPr>
-          <p:cNvPr id="7" name="Etiqueta foto"/>
-          <p:cNvSpPr txBox="1"/>
-          <p:nvPr/>
-        </p:nvSpPr>
-        <p:spPr>
-          <a:xfrm>
-            <a:off x="647700" y="5086350"/>
-            <a:ext cx="2228850" cy="152400"/>
-          </a:xfrm>
-          <a:prstGeom prst="rect">
-            <a:avLst/>
-          </a:prstGeom>
-          <a:noFill/>
-          <a:ln/>
-        </p:spPr>
-        <p:txBody>
-          <a:bodyPr wrap="square" lIns="0" tIns="0" rIns="0" bIns="0" rtlCol="0" anchor="t"/>
-          <a:lstStyle/>
-          <a:p>
-            <a:pPr algn="ctr" indent="0" marL="0">
-              <a:buNone/>
-            </a:pPr>
-            <a:r>
-              <a:rPr lang="en-US" sz="800" dirty="0">
-                <a:solidFill>
-                  <a:schemeClr val="bg1"/>
-                </a:solidFill>
-              </a:rPr>
-              <a:t>Insertar foto: enfermera escaneando brazalete</a:t>
-            </a:r>
-            <a:endParaRPr lang="en-US" sz="800" dirty="0"/>
-          </a:p>
-        </p:txBody>
-      </p:sp>
-      <p:sp>
-        <p:nvSpPr>
-          <p:cNvPr id="8" name="FOTO (reemplazar): brazalete"/>
-          <p:cNvSpPr/>
-          <p:nvPr/>
-        </p:nvSpPr>
-        <p:spPr>
-          <a:xfrm>
-            <a:off x="1809750" y="4286250"/>
-            <a:ext cx="1714500" cy="1714500"/>
-          </a:xfrm>
-          <a:prstGeom prst="ellipse">
-            <a:avLst/>
-          </a:prstGeom>
-          <a:solidFill>
-            <a:schemeClr val="accent6"/>
-          </a:solidFill>
-          <a:ln w="63500">
-            <a:solidFill>
-              <a:schemeClr val="bg1"/>
-            </a:solidFill>
-            <a:prstDash val="solid"/>
-          </a:ln>
-          <a:effectLst>
-            <a:outerShdw sx="100000" sy="100000" kx="0" ky="0" algn="bl" rotWithShape="0" blurRad="177800" dist="38100" dir="5400000">
-              <a:srgbClr val="1E3A8A">
-                <a:alpha val="14000"/>
-              </a:srgbClr>
-            </a:outerShdw>
-          </a:effectLst>
-        </p:spPr>
-      </p:sp>
       <p:pic>
         <p:nvPicPr>
-          <p:cNvPr id="9" name="Image 1" descr="Icono ScanLine">    </p:cNvPr>
+          <p:cNvPr id="6" name="Image 1" descr="Médico con iconos de salud y protección">    </p:cNvPr>
           <p:cNvPicPr>
             <a:picLocks noChangeAspect="1"/>
           </p:cNvPicPr>
@@ -10973,8 +10733,8 @@
         </p:blipFill>
         <p:spPr>
           <a:xfrm>
-            <a:off x="2341245" y="4817745"/>
-            <a:ext cx="651510" cy="651510"/>
+            <a:off x="1809750" y="4191000"/>
+            <a:ext cx="1809750" cy="1809750"/>
           </a:xfrm>
           <a:prstGeom prst="rect">
             <a:avLst/>
@@ -10983,43 +10743,7 @@
       </p:pic>
       <p:sp>
         <p:nvSpPr>
-          <p:cNvPr id="10" name="Etiqueta foto"/>
-          <p:cNvSpPr txBox="1"/>
-          <p:nvPr/>
-        </p:nvSpPr>
-        <p:spPr>
-          <a:xfrm>
-            <a:off x="1885950" y="5753100"/>
-            <a:ext cx="1562100" cy="152400"/>
-          </a:xfrm>
-          <a:prstGeom prst="rect">
-            <a:avLst/>
-          </a:prstGeom>
-          <a:noFill/>
-          <a:ln/>
-        </p:spPr>
-        <p:txBody>
-          <a:bodyPr wrap="square" lIns="0" tIns="0" rIns="0" bIns="0" rtlCol="0" anchor="t"/>
-          <a:lstStyle/>
-          <a:p>
-            <a:pPr algn="ctr" indent="0" marL="0">
-              <a:buNone/>
-            </a:pPr>
-            <a:r>
-              <a:rPr lang="en-US" sz="800" dirty="0">
-                <a:solidFill>
-                  <a:schemeClr val="bg1"/>
-                </a:solidFill>
-              </a:rPr>
-              <a:t>Insertar foto: brazalete</a:t>
-            </a:r>
-            <a:endParaRPr lang="en-US" sz="800" dirty="0"/>
-          </a:p>
-        </p:txBody>
-      </p:sp>
-      <p:sp>
-        <p:nvSpPr>
-          <p:cNvPr id="11" name="Tarjeta"/>
+          <p:cNvPr id="7" name="Tarjeta"/>
           <p:cNvSpPr/>
           <p:nvPr/>
         </p:nvSpPr>
@@ -11053,7 +10777,7 @@
       </p:sp>
       <p:sp>
         <p:nvSpPr>
-          <p:cNvPr id="12" name="Insignia 1"/>
+          <p:cNvPr id="8" name="Insignia 1"/>
           <p:cNvSpPr/>
           <p:nvPr/>
         </p:nvSpPr>
@@ -11073,7 +10797,7 @@
       </p:sp>
       <p:sp>
         <p:nvSpPr>
-          <p:cNvPr id="13" name="Text 9"/>
+          <p:cNvPr id="9" name="Text 5"/>
           <p:cNvSpPr txBox="1"/>
           <p:nvPr/>
         </p:nvSpPr>
@@ -11112,7 +10836,7 @@
       </p:sp>
       <p:sp>
         <p:nvSpPr>
-          <p:cNvPr id="14" name="Text 10"/>
+          <p:cNvPr id="10" name="Text 6"/>
           <p:cNvSpPr txBox="1"/>
           <p:nvPr/>
         </p:nvSpPr>
@@ -11151,7 +10875,7 @@
       </p:sp>
       <p:sp>
         <p:nvSpPr>
-          <p:cNvPr id="15" name="Text 11"/>
+          <p:cNvPr id="11" name="Text 7"/>
           <p:cNvSpPr txBox="1"/>
           <p:nvPr/>
         </p:nvSpPr>
@@ -11187,7 +10911,7 @@
       </p:sp>
       <p:sp>
         <p:nvSpPr>
-          <p:cNvPr id="16" name="Etiqueta GSRN"/>
+          <p:cNvPr id="12" name="Etiqueta GSRN"/>
           <p:cNvSpPr/>
           <p:nvPr/>
         </p:nvSpPr>
@@ -11209,7 +10933,7 @@
       </p:sp>
       <p:sp>
         <p:nvSpPr>
-          <p:cNvPr id="17" name="Text 13"/>
+          <p:cNvPr id="13" name="Text 9"/>
           <p:cNvSpPr txBox="1"/>
           <p:nvPr/>
         </p:nvSpPr>
@@ -11248,7 +10972,7 @@
       </p:sp>
       <p:sp>
         <p:nvSpPr>
-          <p:cNvPr id="18" name="Tarjeta"/>
+          <p:cNvPr id="14" name="Tarjeta"/>
           <p:cNvSpPr/>
           <p:nvPr/>
         </p:nvSpPr>
@@ -11282,7 +11006,7 @@
       </p:sp>
       <p:sp>
         <p:nvSpPr>
-          <p:cNvPr id="19" name="Insignia 2"/>
+          <p:cNvPr id="15" name="Insignia 2"/>
           <p:cNvSpPr/>
           <p:nvPr/>
         </p:nvSpPr>
@@ -11302,7 +11026,7 @@
       </p:sp>
       <p:sp>
         <p:nvSpPr>
-          <p:cNvPr id="20" name="Text 16"/>
+          <p:cNvPr id="16" name="Text 12"/>
           <p:cNvSpPr txBox="1"/>
           <p:nvPr/>
         </p:nvSpPr>
@@ -11341,7 +11065,7 @@
       </p:sp>
       <p:sp>
         <p:nvSpPr>
-          <p:cNvPr id="21" name="Text 17"/>
+          <p:cNvPr id="17" name="Text 13"/>
           <p:cNvSpPr txBox="1"/>
           <p:nvPr/>
         </p:nvSpPr>
@@ -11380,7 +11104,7 @@
       </p:sp>
       <p:sp>
         <p:nvSpPr>
-          <p:cNvPr id="22" name="Text 18"/>
+          <p:cNvPr id="18" name="Text 14"/>
           <p:cNvSpPr txBox="1"/>
           <p:nvPr/>
         </p:nvSpPr>
@@ -11416,7 +11140,7 @@
       </p:sp>
       <p:sp>
         <p:nvSpPr>
-          <p:cNvPr id="23" name="Etiqueta GTIN"/>
+          <p:cNvPr id="19" name="Etiqueta GTIN"/>
           <p:cNvSpPr/>
           <p:nvPr/>
         </p:nvSpPr>
@@ -11438,7 +11162,7 @@
       </p:sp>
       <p:sp>
         <p:nvSpPr>
-          <p:cNvPr id="24" name="Text 20"/>
+          <p:cNvPr id="20" name="Text 16"/>
           <p:cNvSpPr txBox="1"/>
           <p:nvPr/>
         </p:nvSpPr>
@@ -11477,7 +11201,7 @@
       </p:sp>
       <p:sp>
         <p:nvSpPr>
-          <p:cNvPr id="25" name="Tarjeta"/>
+          <p:cNvPr id="21" name="Tarjeta"/>
           <p:cNvSpPr/>
           <p:nvPr/>
         </p:nvSpPr>
@@ -11511,7 +11235,7 @@
       </p:sp>
       <p:sp>
         <p:nvSpPr>
-          <p:cNvPr id="26" name="Insignia 3"/>
+          <p:cNvPr id="22" name="Insignia 3"/>
           <p:cNvSpPr/>
           <p:nvPr/>
         </p:nvSpPr>
@@ -11531,7 +11255,7 @@
       </p:sp>
       <p:sp>
         <p:nvSpPr>
-          <p:cNvPr id="27" name="Text 23"/>
+          <p:cNvPr id="23" name="Text 19"/>
           <p:cNvSpPr txBox="1"/>
           <p:nvPr/>
         </p:nvSpPr>
@@ -11570,7 +11294,7 @@
       </p:sp>
       <p:sp>
         <p:nvSpPr>
-          <p:cNvPr id="28" name="Text 24"/>
+          <p:cNvPr id="24" name="Text 20"/>
           <p:cNvSpPr txBox="1"/>
           <p:nvPr/>
         </p:nvSpPr>
@@ -11609,7 +11333,7 @@
       </p:sp>
       <p:sp>
         <p:nvSpPr>
-          <p:cNvPr id="29" name="Text 25"/>
+          <p:cNvPr id="25" name="Text 21"/>
           <p:cNvSpPr txBox="1"/>
           <p:nvPr/>
         </p:nvSpPr>
@@ -11645,7 +11369,7 @@
       </p:sp>
       <p:sp>
         <p:nvSpPr>
-          <p:cNvPr id="30" name="Etiqueta LASA"/>
+          <p:cNvPr id="26" name="Etiqueta LASA"/>
           <p:cNvSpPr/>
           <p:nvPr/>
         </p:nvSpPr>
@@ -11667,7 +11391,7 @@
       </p:sp>
       <p:sp>
         <p:nvSpPr>
-          <p:cNvPr id="31" name="Text 27"/>
+          <p:cNvPr id="27" name="Text 23"/>
           <p:cNvSpPr txBox="1"/>
           <p:nvPr/>
         </p:nvSpPr>
@@ -11706,7 +11430,7 @@
       </p:sp>
       <p:sp>
         <p:nvSpPr>
-          <p:cNvPr id="32" name="Tarjeta"/>
+          <p:cNvPr id="28" name="Tarjeta"/>
           <p:cNvSpPr/>
           <p:nvPr/>
         </p:nvSpPr>
@@ -11740,7 +11464,7 @@
       </p:sp>
       <p:sp>
         <p:nvSpPr>
-          <p:cNvPr id="33" name="Insignia 4"/>
+          <p:cNvPr id="29" name="Insignia 4"/>
           <p:cNvSpPr/>
           <p:nvPr/>
         </p:nvSpPr>
@@ -11760,7 +11484,7 @@
       </p:sp>
       <p:sp>
         <p:nvSpPr>
-          <p:cNvPr id="34" name="Text 30"/>
+          <p:cNvPr id="30" name="Text 26"/>
           <p:cNvSpPr txBox="1"/>
           <p:nvPr/>
         </p:nvSpPr>
@@ -11799,7 +11523,7 @@
       </p:sp>
       <p:sp>
         <p:nvSpPr>
-          <p:cNvPr id="35" name="Text 31"/>
+          <p:cNvPr id="31" name="Text 27"/>
           <p:cNvSpPr txBox="1"/>
           <p:nvPr/>
         </p:nvSpPr>
@@ -11838,7 +11562,7 @@
       </p:sp>
       <p:sp>
         <p:nvSpPr>
-          <p:cNvPr id="36" name="Text 32"/>
+          <p:cNvPr id="32" name="Text 28"/>
           <p:cNvSpPr txBox="1"/>
           <p:nvPr/>
         </p:nvSpPr>
@@ -11874,7 +11598,7 @@
       </p:sp>
       <p:sp>
         <p:nvSpPr>
-          <p:cNvPr id="37" name="Etiqueta HCE"/>
+          <p:cNvPr id="33" name="Etiqueta HCE"/>
           <p:cNvSpPr/>
           <p:nvPr/>
         </p:nvSpPr>
@@ -11896,7 +11620,7 @@
       </p:sp>
       <p:sp>
         <p:nvSpPr>
-          <p:cNvPr id="38" name="Text 34"/>
+          <p:cNvPr id="34" name="Text 30"/>
           <p:cNvSpPr txBox="1"/>
           <p:nvPr/>
         </p:nvSpPr>
@@ -11935,7 +11659,7 @@
       </p:sp>
       <p:sp>
         <p:nvSpPr>
-          <p:cNvPr id="39" name="Tarjeta"/>
+          <p:cNvPr id="35" name="Tarjeta"/>
           <p:cNvSpPr/>
           <p:nvPr/>
         </p:nvSpPr>
@@ -11969,7 +11693,7 @@
       </p:sp>
       <p:sp>
         <p:nvSpPr>
-          <p:cNvPr id="40" name="Insignia 5"/>
+          <p:cNvPr id="36" name="Insignia 5"/>
           <p:cNvSpPr/>
           <p:nvPr/>
         </p:nvSpPr>
@@ -11989,7 +11713,7 @@
       </p:sp>
       <p:sp>
         <p:nvSpPr>
-          <p:cNvPr id="41" name="Text 37"/>
+          <p:cNvPr id="37" name="Text 33"/>
           <p:cNvSpPr txBox="1"/>
           <p:nvPr/>
         </p:nvSpPr>
@@ -12028,7 +11752,7 @@
       </p:sp>
       <p:sp>
         <p:nvSpPr>
-          <p:cNvPr id="42" name="Text 38"/>
+          <p:cNvPr id="38" name="Text 34"/>
           <p:cNvSpPr txBox="1"/>
           <p:nvPr/>
         </p:nvSpPr>
@@ -12067,7 +11791,7 @@
       </p:sp>
       <p:sp>
         <p:nvSpPr>
-          <p:cNvPr id="43" name="Text 39"/>
+          <p:cNvPr id="39" name="Text 35"/>
           <p:cNvSpPr txBox="1"/>
           <p:nvPr/>
         </p:nvSpPr>
@@ -12103,7 +11827,7 @@
       </p:sp>
       <p:pic>
         <p:nvPicPr>
-          <p:cNvPr id="44" name="Image 2" descr="Icono Ban">    </p:cNvPr>
+          <p:cNvPr id="40" name="Image 2" descr="Icono Ban">    </p:cNvPr>
           <p:cNvPicPr>
             <a:picLocks noChangeAspect="1"/>
           </p:cNvPicPr>

</xml_diff>